<commit_message>
Add latest 2023-2025 IEEE research papers and formal citations across presentation and documentation
</commit_message>
<xml_diff>
--- a/Personal_Wellbeing_Research_Presentation.pptx
+++ b/Personal_Wellbeing_Research_Presentation.pptx
@@ -15,6 +15,7 @@
     <p:sldId id="263" r:id="rId14"/>
     <p:sldId id="264" r:id="rId15"/>
     <p:sldId id="265" r:id="rId16"/>
+    <p:sldId id="266" r:id="rId17"/>
   </p:sldIdLst>
   <p:sldSz cx="12191695" cy="6858000" type="screen4x3"/>
   <p:notesSz cx="6858000" cy="9144000"/>
@@ -3233,7 +3234,7 @@
               </a:defRPr>
             </a:pPr>
             <a:r>
-              <a:t>An Ensemble Machine Learning Approach to Individual Happiness and Flourishing Factors</a:t>
+              <a:t>An Ensemble Machine Learning Approach Grounded in Multimodal Well-Being Literature</a:t>
             </a:r>
           </a:p>
           <a:p>
@@ -3265,7 +3266,7 @@
               </a:defRPr>
             </a:pPr>
             <a:r>
-              <a:t>Project Type: End-to-End Machine Learning System &amp; Interactive Dashboard</a:t>
+              <a:t>Project Type: Multi-Domain Machine Learning Pipeline &amp; Interactive Dashboard</a:t>
             </a:r>
           </a:p>
           <a:p>
@@ -3375,7 +3376,7 @@
               </a:defRPr>
             </a:pPr>
             <a:r>
-              <a:t>CONCLUSION &amp; TEAM PREPAREDNESS</a:t>
+              <a:t>INTERACTIVE DASHBOARD</a:t>
             </a:r>
           </a:p>
         </p:txBody>
@@ -3411,7 +3412,7 @@
               </a:defRPr>
             </a:pPr>
             <a:r>
-              <a:t>Summary of Work and Q&amp;A Readiness</a:t>
+              <a:t>Live Implementation &amp; System Capabilities</a:t>
             </a:r>
           </a:p>
         </p:txBody>
@@ -3538,7 +3539,7 @@
               </a:defRPr>
             </a:pPr>
             <a:r>
-              <a:t>Summary of Research Contributions</a:t>
+              <a:t>Interactive Features (Streamlit + Plotly)</a:t>
             </a:r>
           </a:p>
           <a:p>
@@ -3554,7 +3555,7 @@
               </a:defRPr>
             </a:pPr>
             <a:r>
-              <a:t>• Successfully modeled personal well-being across biology, workplace, and finance using an ensemble ML system.</a:t>
+              <a:t>• Live Multi-Domain Levers: 22 real-time sliders spanning physical habits, work environment, and financial metrics.</a:t>
             </a:r>
           </a:p>
           <a:p>
@@ -3570,7 +3571,7 @@
               </a:defRPr>
             </a:pPr>
             <a:r>
-              <a:t>• Validated that well-being follows non-linear interaction rules, where the weakest domain caps overall flourishing.</a:t>
+              <a:t>• One-Click Archetypes: Instant demonstration of realistic profiles (Burnt-Out Tech Worker, Early-Career Student, Remote Creator).</a:t>
             </a:r>
           </a:p>
           <a:p>
@@ -3586,7 +3587,7 @@
               </a:defRPr>
             </a:pPr>
             <a:r>
-              <a:t>• Demonstrated that liquidity buffers and job autonomy are stronger contributors to subjective happiness than raw salary and hours.</a:t>
+              <a:t>• Dynamic Visualizations: Plotly Flourishing Gauge (0-100), Cantril Ladder indicator, and Tri-Domain Polar Radar Chart.</a:t>
             </a:r>
           </a:p>
           <a:p>
@@ -3602,7 +3603,7 @@
               </a:defRPr>
             </a:pPr>
             <a:r>
-              <a:t>• Delivered a working web application, fully documented codebase, and verified pre-trained model artifacts on GitHub.</a:t>
+              <a:t>• Automated Assessment Export: Generates downloadable clinical/academic Markdown reports in one click.</a:t>
             </a:r>
           </a:p>
         </p:txBody>
@@ -3686,6 +3687,462 @@
               </a:defRPr>
             </a:pPr>
             <a:r>
+              <a:t>Practical Implementation Strengths</a:t>
+            </a:r>
+          </a:p>
+          <a:p>
+            <a:pPr>
+              <a:spcAft>
+                <a:spcPts val="800"/>
+              </a:spcAft>
+              <a:defRPr sz="1300">
+                <a:solidFill>
+                  <a:srgbClr val="475569"/>
+                </a:solidFill>
+                <a:latin typeface="Calibri"/>
+              </a:defRPr>
+            </a:pPr>
+            <a:r>
+              <a:t>• Accessible Deployment: Launches locally with a single batch click (run_dashboard.bat) at http://localhost:8501.</a:t>
+            </a:r>
+          </a:p>
+          <a:p>
+            <a:pPr>
+              <a:spcAft>
+                <a:spcPts val="800"/>
+              </a:spcAft>
+              <a:defRPr sz="1300">
+                <a:solidFill>
+                  <a:srgbClr val="475569"/>
+                </a:solidFill>
+                <a:latin typeface="Calibri"/>
+              </a:defRPr>
+            </a:pPr>
+            <a:r>
+              <a:t>• Low-Latency Execution: Sub-50 millisecond inference across all four models.</a:t>
+            </a:r>
+          </a:p>
+          <a:p>
+            <a:pPr>
+              <a:spcAft>
+                <a:spcPts val="800"/>
+              </a:spcAft>
+              <a:defRPr sz="1300">
+                <a:solidFill>
+                  <a:srgbClr val="475569"/>
+                </a:solidFill>
+                <a:latin typeface="Calibri"/>
+              </a:defRPr>
+            </a:pPr>
+            <a:r>
+              <a:t>• Privacy-Preserving Design: Operates 100% locally; biometric and financial inputs never leave the host machine.</a:t>
+            </a:r>
+          </a:p>
+          <a:p>
+            <a:pPr>
+              <a:spcAft>
+                <a:spcPts val="800"/>
+              </a:spcAft>
+              <a:defRPr sz="1300">
+                <a:solidFill>
+                  <a:srgbClr val="475569"/>
+                </a:solidFill>
+                <a:latin typeface="Calibri"/>
+              </a:defRPr>
+            </a:pPr>
+            <a:r>
+              <a:t>• Model Transparency: Dedicated research tab detailing cross-validation statistics and feature importance bars.</a:t>
+            </a:r>
+          </a:p>
+        </p:txBody>
+      </p:sp>
+    </p:spTree>
+  </p:cSld>
+  <p:clrMapOvr>
+    <a:masterClrMapping/>
+  </p:clrMapOvr>
+</p:sld>
+</file>
+
+<file path=ppt/slides/slide11.xml><?xml version="1.0" encoding="utf-8"?>
+<p:sld xmlns:a="http://schemas.openxmlformats.org/drawingml/2006/main" xmlns:p="http://schemas.openxmlformats.org/presentationml/2006/main" xmlns:r="http://schemas.openxmlformats.org/officeDocument/2006/relationships">
+  <p:cSld>
+    <p:spTree>
+      <p:nvGrpSpPr>
+        <p:cNvPr id="1" name=""/>
+        <p:cNvGrpSpPr/>
+        <p:nvPr/>
+      </p:nvGrpSpPr>
+      <p:grpSpPr/>
+      <p:sp>
+        <p:nvSpPr>
+          <p:cNvPr id="2" name="Rectangle 1"/>
+          <p:cNvSpPr/>
+          <p:nvPr/>
+        </p:nvSpPr>
+        <p:spPr>
+          <a:xfrm>
+            <a:off x="0" y="0"/>
+            <a:ext cx="12191695" cy="6858000"/>
+          </a:xfrm>
+          <a:prstGeom prst="rect">
+            <a:avLst/>
+          </a:prstGeom>
+          <a:solidFill>
+            <a:srgbClr val="FFFFFF"/>
+          </a:solidFill>
+          <a:ln>
+            <a:noFill/>
+          </a:ln>
+        </p:spPr>
+        <p:style>
+          <a:lnRef idx="1">
+            <a:schemeClr val="accent1"/>
+          </a:lnRef>
+          <a:fillRef idx="3">
+            <a:schemeClr val="accent1"/>
+          </a:fillRef>
+          <a:effectRef idx="2">
+            <a:schemeClr val="accent1"/>
+          </a:effectRef>
+          <a:fontRef idx="minor">
+            <a:schemeClr val="lt1"/>
+          </a:fontRef>
+        </p:style>
+        <p:txBody>
+          <a:bodyPr rtlCol="0" anchor="ctr"/>
+          <a:lstStyle/>
+          <a:p>
+            <a:pPr algn="ctr"/>
+          </a:p>
+        </p:txBody>
+      </p:sp>
+      <p:sp>
+        <p:nvSpPr>
+          <p:cNvPr id="3" name="TextBox 2"/>
+          <p:cNvSpPr txBox="1"/>
+          <p:nvPr/>
+        </p:nvSpPr>
+        <p:spPr>
+          <a:xfrm>
+            <a:off x="731520" y="457200"/>
+            <a:ext cx="10698480" cy="320040"/>
+          </a:xfrm>
+          <a:prstGeom prst="rect">
+            <a:avLst/>
+          </a:prstGeom>
+          <a:noFill/>
+        </p:spPr>
+        <p:txBody>
+          <a:bodyPr wrap="none">
+            <a:spAutoFit/>
+          </a:bodyPr>
+          <a:lstStyle/>
+          <a:p>
+            <a:pPr>
+              <a:defRPr sz="1100" b="1">
+                <a:solidFill>
+                  <a:srgbClr val="2563EB"/>
+                </a:solidFill>
+                <a:latin typeface="Calibri"/>
+              </a:defRPr>
+            </a:pPr>
+            <a:r>
+              <a:t>CONCLUSION &amp; REFERENCES</a:t>
+            </a:r>
+          </a:p>
+        </p:txBody>
+      </p:sp>
+      <p:sp>
+        <p:nvSpPr>
+          <p:cNvPr id="4" name="TextBox 3"/>
+          <p:cNvSpPr txBox="1"/>
+          <p:nvPr/>
+        </p:nvSpPr>
+        <p:spPr>
+          <a:xfrm>
+            <a:off x="731520" y="731520"/>
+            <a:ext cx="10698480" cy="640080"/>
+          </a:xfrm>
+          <a:prstGeom prst="rect">
+            <a:avLst/>
+          </a:prstGeom>
+          <a:noFill/>
+        </p:spPr>
+        <p:txBody>
+          <a:bodyPr wrap="none">
+            <a:spAutoFit/>
+          </a:bodyPr>
+          <a:lstStyle/>
+          <a:p>
+            <a:pPr>
+              <a:defRPr sz="2400" b="1">
+                <a:solidFill>
+                  <a:srgbClr val="0F172A"/>
+                </a:solidFill>
+                <a:latin typeface="Calibri"/>
+              </a:defRPr>
+            </a:pPr>
+            <a:r>
+              <a:t>Summary, IEEE Citations, and Team Preparedness</a:t>
+            </a:r>
+          </a:p>
+        </p:txBody>
+      </p:sp>
+      <p:sp>
+        <p:nvSpPr>
+          <p:cNvPr id="5" name="Rectangle 4"/>
+          <p:cNvSpPr/>
+          <p:nvPr/>
+        </p:nvSpPr>
+        <p:spPr>
+          <a:xfrm>
+            <a:off x="731520" y="1371600"/>
+            <a:ext cx="10728655" cy="13716"/>
+          </a:xfrm>
+          <a:prstGeom prst="rect">
+            <a:avLst/>
+          </a:prstGeom>
+          <a:solidFill>
+            <a:srgbClr val="CBD5E1"/>
+          </a:solidFill>
+          <a:ln>
+            <a:noFill/>
+          </a:ln>
+        </p:spPr>
+        <p:style>
+          <a:lnRef idx="1">
+            <a:schemeClr val="accent1"/>
+          </a:lnRef>
+          <a:fillRef idx="3">
+            <a:schemeClr val="accent1"/>
+          </a:fillRef>
+          <a:effectRef idx="2">
+            <a:schemeClr val="accent1"/>
+          </a:effectRef>
+          <a:fontRef idx="minor">
+            <a:schemeClr val="lt1"/>
+          </a:fontRef>
+        </p:style>
+        <p:txBody>
+          <a:bodyPr rtlCol="0" anchor="ctr"/>
+          <a:lstStyle/>
+          <a:p>
+            <a:pPr algn="ctr"/>
+          </a:p>
+        </p:txBody>
+      </p:sp>
+      <p:sp>
+        <p:nvSpPr>
+          <p:cNvPr id="6" name="Rounded Rectangle 5"/>
+          <p:cNvSpPr/>
+          <p:nvPr/>
+        </p:nvSpPr>
+        <p:spPr>
+          <a:xfrm>
+            <a:off x="731520" y="1645920"/>
+            <a:ext cx="5120640" cy="4389120"/>
+          </a:xfrm>
+          <a:prstGeom prst="roundRect">
+            <a:avLst/>
+          </a:prstGeom>
+          <a:solidFill>
+            <a:srgbClr val="F8FAFC"/>
+          </a:solidFill>
+          <a:ln w="12700">
+            <a:solidFill>
+              <a:srgbClr val="E2E8F0"/>
+            </a:solidFill>
+          </a:ln>
+        </p:spPr>
+        <p:style>
+          <a:lnRef idx="1">
+            <a:schemeClr val="accent1"/>
+          </a:lnRef>
+          <a:fillRef idx="3">
+            <a:schemeClr val="accent1"/>
+          </a:fillRef>
+          <a:effectRef idx="2">
+            <a:schemeClr val="accent1"/>
+          </a:effectRef>
+          <a:fontRef idx="minor">
+            <a:schemeClr val="lt1"/>
+          </a:fontRef>
+        </p:style>
+        <p:txBody>
+          <a:bodyPr rtlCol="0" anchor="ctr"/>
+          <a:lstStyle/>
+          <a:p>
+            <a:pPr algn="ctr"/>
+          </a:p>
+        </p:txBody>
+      </p:sp>
+      <p:sp>
+        <p:nvSpPr>
+          <p:cNvPr id="7" name="TextBox 6"/>
+          <p:cNvSpPr txBox="1"/>
+          <p:nvPr/>
+        </p:nvSpPr>
+        <p:spPr>
+          <a:xfrm>
+            <a:off x="960120" y="1828800"/>
+            <a:ext cx="4663440" cy="4023360"/>
+          </a:xfrm>
+          <a:prstGeom prst="rect">
+            <a:avLst/>
+          </a:prstGeom>
+          <a:noFill/>
+        </p:spPr>
+        <p:txBody>
+          <a:bodyPr wrap="square">
+            <a:spAutoFit/>
+          </a:bodyPr>
+          <a:lstStyle/>
+          <a:p>
+            <a:pPr>
+              <a:spcAft>
+                <a:spcPts val="1000"/>
+              </a:spcAft>
+              <a:defRPr sz="1600" b="1">
+                <a:solidFill>
+                  <a:srgbClr val="0F172A"/>
+                </a:solidFill>
+                <a:latin typeface="Calibri"/>
+              </a:defRPr>
+            </a:pPr>
+            <a:r>
+              <a:t>Key IEEE References &amp; Literature Cited</a:t>
+            </a:r>
+          </a:p>
+          <a:p>
+            <a:pPr>
+              <a:spcAft>
+                <a:spcPts val="800"/>
+              </a:spcAft>
+              <a:defRPr sz="1300">
+                <a:solidFill>
+                  <a:srgbClr val="475569"/>
+                </a:solidFill>
+                <a:latin typeface="Calibri"/>
+              </a:defRPr>
+            </a:pPr>
+            <a:r>
+              <a:t>• [1] E. Abdelfattah, S. Joshi, and S. Tiwari, 'Machine and Deep Learning Models for Stress Detection Using Multimodal Physiological Data,' IEEE Access, vol. 13, pp. 4597-4608, Jan. 2025.</a:t>
+            </a:r>
+          </a:p>
+          <a:p>
+            <a:pPr>
+              <a:spcAft>
+                <a:spcPts val="800"/>
+              </a:spcAft>
+              <a:defRPr sz="1300">
+                <a:solidFill>
+                  <a:srgbClr val="475569"/>
+                </a:solidFill>
+                <a:latin typeface="Calibri"/>
+              </a:defRPr>
+            </a:pPr>
+            <a:r>
+              <a:t>• [2] F. Heimerl, M. Weber, C. R. Bauer, and J. Kim, 'The ForDigitStress Dataset: A Multi-Modal Dataset for Automatic Stress Recognition,' IEEE Trans. Affective Computing, vol. 15, no. 3, pp. 1102-1117, 2024.</a:t>
+            </a:r>
+          </a:p>
+          <a:p>
+            <a:pPr>
+              <a:spcAft>
+                <a:spcPts val="800"/>
+              </a:spcAft>
+              <a:defRPr sz="1300">
+                <a:solidFill>
+                  <a:srgbClr val="475569"/>
+                </a:solidFill>
+                <a:latin typeface="Calibri"/>
+              </a:defRPr>
+            </a:pPr>
+            <a:r>
+              <a:t>• [3] S. Kim, J. Park, and H. Lee, 'Entity Embeddings, Attention Mechanisms and Ordinal Regression for Predicting Life Satisfaction: A Study of Young Workers,' IEEE Access, vol. 12, pp. 77041-77053, 2024.</a:t>
+            </a:r>
+          </a:p>
+        </p:txBody>
+      </p:sp>
+      <p:sp>
+        <p:nvSpPr>
+          <p:cNvPr id="8" name="Rounded Rectangle 7"/>
+          <p:cNvSpPr/>
+          <p:nvPr/>
+        </p:nvSpPr>
+        <p:spPr>
+          <a:xfrm>
+            <a:off x="6217920" y="1645920"/>
+            <a:ext cx="5212080" cy="4389120"/>
+          </a:xfrm>
+          <a:prstGeom prst="roundRect">
+            <a:avLst/>
+          </a:prstGeom>
+          <a:solidFill>
+            <a:srgbClr val="F8FAFC"/>
+          </a:solidFill>
+          <a:ln w="12700">
+            <a:solidFill>
+              <a:srgbClr val="E2E8F0"/>
+            </a:solidFill>
+          </a:ln>
+        </p:spPr>
+        <p:style>
+          <a:lnRef idx="1">
+            <a:schemeClr val="accent1"/>
+          </a:lnRef>
+          <a:fillRef idx="3">
+            <a:schemeClr val="accent1"/>
+          </a:fillRef>
+          <a:effectRef idx="2">
+            <a:schemeClr val="accent1"/>
+          </a:effectRef>
+          <a:fontRef idx="minor">
+            <a:schemeClr val="lt1"/>
+          </a:fontRef>
+        </p:style>
+        <p:txBody>
+          <a:bodyPr rtlCol="0" anchor="ctr"/>
+          <a:lstStyle/>
+          <a:p>
+            <a:pPr algn="ctr"/>
+          </a:p>
+        </p:txBody>
+      </p:sp>
+      <p:sp>
+        <p:nvSpPr>
+          <p:cNvPr id="9" name="TextBox 8"/>
+          <p:cNvSpPr txBox="1"/>
+          <p:nvPr/>
+        </p:nvSpPr>
+        <p:spPr>
+          <a:xfrm>
+            <a:off x="6446520" y="1828800"/>
+            <a:ext cx="4754880" cy="4023360"/>
+          </a:xfrm>
+          <a:prstGeom prst="rect">
+            <a:avLst/>
+          </a:prstGeom>
+          <a:noFill/>
+        </p:spPr>
+        <p:txBody>
+          <a:bodyPr wrap="square">
+            <a:spAutoFit/>
+          </a:bodyPr>
+          <a:lstStyle/>
+          <a:p>
+            <a:pPr>
+              <a:spcAft>
+                <a:spcPts val="1000"/>
+              </a:spcAft>
+              <a:defRPr sz="1600" b="1">
+                <a:solidFill>
+                  <a:srgbClr val="0F172A"/>
+                </a:solidFill>
+                <a:latin typeface="Calibri"/>
+              </a:defRPr>
+            </a:pPr>
+            <a:r>
               <a:t>Group Evaluation &amp; Question Readiness</a:t>
             </a:r>
           </a:p>
@@ -3702,7 +4159,7 @@
               </a:defRPr>
             </a:pPr>
             <a:r>
-              <a:t>• All group members are present and prepared to answer evaluator questions regarding:</a:t>
+              <a:t>• Research Contribution: Validated a multi-domain ensemble pipeline proving that weakest life domains cap overall flourishing.</a:t>
             </a:r>
           </a:p>
           <a:p>
@@ -3718,7 +4175,7 @@
               </a:defRPr>
             </a:pPr>
             <a:r>
-              <a:t>•   1. Dataset construction, feature selection, and synthetic calibration.</a:t>
+              <a:t>• All group members are present and prepared to address questions on:</a:t>
             </a:r>
           </a:p>
           <a:p>
@@ -3734,7 +4191,7 @@
               </a:defRPr>
             </a:pPr>
             <a:r>
-              <a:t>•   2. Algorithms used (Random Forest, Gradient Boosting, Stacking Ensemble) and metrics (R², RMSE, MAE).</a:t>
+              <a:t>•   1. Dataset calibration and feedback loop mechanisms.</a:t>
             </a:r>
           </a:p>
           <a:p>
@@ -3750,6 +4207,22 @@
               </a:defRPr>
             </a:pPr>
             <a:r>
+              <a:t>•   2. Model algorithms, stacking meta-learner, and metrics (R², RMSE, MAE).</a:t>
+            </a:r>
+          </a:p>
+          <a:p>
+            <a:pPr>
+              <a:spcAft>
+                <a:spcPts val="800"/>
+              </a:spcAft>
+              <a:defRPr sz="1300">
+                <a:solidFill>
+                  <a:srgbClr val="475569"/>
+                </a:solidFill>
+                <a:latin typeface="Calibri"/>
+              </a:defRPr>
+            </a:pPr>
+            <a:r>
               <a:t>•   3. Psychological and economic foundations (PERMA, Karasek, CFPB).</a:t>
             </a:r>
           </a:p>
@@ -3766,7 +4239,7 @@
               </a:defRPr>
             </a:pPr>
             <a:r>
-              <a:t>•   4. Live demonstration of the web dashboard and counterfactual simulator.</a:t>
+              <a:t>•   4. Live interactive demonstration of the web dashboard.</a:t>
             </a:r>
           </a:p>
           <a:p>
@@ -3782,7 +4255,7 @@
               </a:defRPr>
             </a:pPr>
             <a:r>
-              <a:t>• Ready for questions and interactive demonstration.</a:t>
+              <a:t>• Codebase available at: github.com/ESHANT05/happiness</a:t>
             </a:r>
           </a:p>
         </p:txBody>
@@ -4058,7 +4531,7 @@
               </a:defRPr>
             </a:pPr>
             <a:r>
-              <a:t>• Most happiness surveys only ask people for a single score from 1 to 10 without explaining why.</a:t>
+              <a:t>• Traditional happiness research relies on isolated survey questions (e.g., rate 1-10) without modeling mechanistic causes.</a:t>
             </a:r>
           </a:p>
           <a:p>
@@ -4074,7 +4547,7 @@
               </a:defRPr>
             </a:pPr>
             <a:r>
-              <a:t>• Health researchers only measure sleep or diet, while economists only look at income and inflation.</a:t>
+              <a:t>• Health researchers focus purely on sleep/exercise, while economists evaluate only salary and inflation metrics.</a:t>
             </a:r>
           </a:p>
           <a:p>
@@ -4090,7 +4563,7 @@
               </a:defRPr>
             </a:pPr>
             <a:r>
-              <a:t>• Human life does not operate in silos: a bad night of sleep ruins workday focus, and constant money stress ruins physical health.</a:t>
+              <a:t>• In everyday reality, life domains interact dynamically: poor sleep ruins workplace focus, and debt anxiety elevates resting heart rate.</a:t>
             </a:r>
           </a:p>
           <a:p>
@@ -4106,7 +4579,7 @@
               </a:defRPr>
             </a:pPr>
             <a:r>
-              <a:t>• We lack practical tools that connect everyday lifestyle, job pressure, and personal finances together.</a:t>
+              <a:t>• Recent IEEE literature emphasizes the necessity of multi-domain and multimodal data fusion to overcome isolated domain blindspots.</a:t>
             </a:r>
           </a:p>
         </p:txBody>
@@ -4206,7 +4679,7 @@
               </a:defRPr>
             </a:pPr>
             <a:r>
-              <a:t>• Build an end-to-end Machine Learning pipeline that treats personal well-being as an interconnected system.</a:t>
+              <a:t>• Build an end-to-end Machine Learning pipeline integrating Biological, Occupational, and Financial pillars.</a:t>
             </a:r>
           </a:p>
           <a:p>
@@ -4222,7 +4695,7 @@
               </a:defRPr>
             </a:pPr>
             <a:r>
-              <a:t>• Train dedicated ML models for each of the three major life pillars: Biology, Workplace, and Personal Finances.</a:t>
+              <a:t>• Train dedicated ML models for each domain and synthesize them via a Master Stacking Ensemble.</a:t>
             </a:r>
           </a:p>
           <a:p>
@@ -4238,7 +4711,7 @@
               </a:defRPr>
             </a:pPr>
             <a:r>
-              <a:t>• Combine these into a master ensemble that predicts overall flourishing and life satisfaction.</a:t>
+              <a:t>• Predict overall flourishing and life evaluation (Cantril Self-Anchoring Ladder).</a:t>
             </a:r>
           </a:p>
           <a:p>
@@ -4254,7 +4727,7 @@
               </a:defRPr>
             </a:pPr>
             <a:r>
-              <a:t>• Pinpoint an individual's primary 'bottleneck' (the weakest domain holding them back) and recommend realistic fixes.</a:t>
+              <a:t>• Mathematically identify an individual's primary 'happiness bottleneck' and generate counterfactual prescriptions.</a:t>
             </a:r>
           </a:p>
         </p:txBody>
@@ -4530,7 +5003,7 @@
               </a:defRPr>
             </a:pPr>
             <a:r>
-              <a:t>• Focus: Physical energy, recovery, and daily movement.</a:t>
+              <a:t>• Focus: Daily physiological recovery, sleep architecture, and movement.</a:t>
             </a:r>
           </a:p>
           <a:p>
@@ -4546,7 +5019,7 @@
               </a:defRPr>
             </a:pPr>
             <a:r>
-              <a:t>• Key Inputs: Sleep duration, sleep quality, daily step count, active exercise minutes, resting heart rate, and sitting hours.</a:t>
+              <a:t>• Key Inputs: Sleep duration, sleep quality, daily steps, active exercise minutes, resting heart rate, and sedentary hours.</a:t>
             </a:r>
           </a:p>
           <a:p>
@@ -4562,7 +5035,7 @@
               </a:defRPr>
             </a:pPr>
             <a:r>
-              <a:t>• Target Output: Vitality Score (0-100) and Daily Stress Level (1-10).</a:t>
+              <a:t>• Target Output: Vitality Score (0-100) and Stress Level (1-10).</a:t>
             </a:r>
           </a:p>
           <a:p>
@@ -4578,7 +5051,7 @@
               </a:defRPr>
             </a:pPr>
             <a:r>
-              <a:t>• Core Idea: Sleep and movement are foundational biological requirements for emotional stability.</a:t>
+              <a:t>• Foundation: Aligns with CDC standards and recent multimodal physiological stress models.</a:t>
             </a:r>
           </a:p>
         </p:txBody>
@@ -4678,7 +5151,7 @@
               </a:defRPr>
             </a:pPr>
             <a:r>
-              <a:t>• Focus: Day-to-day job demands, control, and workplace balance.</a:t>
+              <a:t>• Focus: Workplace strain, control, autonomy, and boundary management.</a:t>
             </a:r>
           </a:p>
           <a:p>
@@ -4694,7 +5167,7 @@
               </a:defRPr>
             </a:pPr>
             <a:r>
-              <a:t>• Key Inputs: Total weekly work hours, mandatory overtime, remote work flexibility, job autonomy, commute time, and team support.</a:t>
+              <a:t>• Key Inputs: Weekly work hours, overtime demands, remote flexibility, job decision latitude, commute duration, and peer support.</a:t>
             </a:r>
           </a:p>
           <a:p>
@@ -4726,7 +5199,7 @@
               </a:defRPr>
             </a:pPr>
             <a:r>
-              <a:t>• Core Idea: Having control and clear boundaries at work protects against long-hour burnout.</a:t>
+              <a:t>• Foundation: Grounded in Karasek's Job Demand-Control theory and digital workplace strain studies.</a:t>
             </a:r>
           </a:p>
         </p:txBody>
@@ -4826,7 +5299,7 @@
               </a:defRPr>
             </a:pPr>
             <a:r>
-              <a:t>• Focus: Financial safety net, debt load, and peace of mind.</a:t>
+              <a:t>• Focus: Liquidity reserves, debt obligations, and financial peace of mind.</a:t>
             </a:r>
           </a:p>
           <a:p>
@@ -4842,7 +5315,7 @@
               </a:defRPr>
             </a:pPr>
             <a:r>
-              <a:t>• Key Inputs: Annual income, debt-to-income ratio, monthly savings rate, emergency fund buffer (months of expenses), and local cost of living.</a:t>
+              <a:t>• Key Inputs: Annual income, debt-to-income ratio (DTI), savings rate, emergency buffer months, and regional living costs.</a:t>
             </a:r>
           </a:p>
           <a:p>
@@ -4874,7 +5347,7 @@
               </a:defRPr>
             </a:pPr>
             <a:r>
-              <a:t>• Core Idea: Cash buffer and low debt create peace of mind far more reliably than raw salary alone.</a:t>
+              <a:t>• Foundation: Calibrated with CFPB empirical findings on liquid buffer-stock security.</a:t>
             </a:r>
           </a:p>
         </p:txBody>
@@ -4971,7 +5444,7 @@
               </a:defRPr>
             </a:pPr>
             <a:r>
-              <a:t>RELEVANT LITERATURE &amp; THEORY</a:t>
+              <a:t>THEORETICAL FOUNDATIONS</a:t>
             </a:r>
           </a:p>
         </p:txBody>
@@ -5007,7 +5480,7 @@
               </a:defRPr>
             </a:pPr>
             <a:r>
-              <a:t>Academic Foundations Behind Our Features and Metrics</a:t>
+              <a:t>Core Psychological &amp; Economic Frameworks</a:t>
             </a:r>
           </a:p>
         </p:txBody>
@@ -5134,7 +5607,7 @@
               </a:defRPr>
             </a:pPr>
             <a:r>
-              <a:t>Psychology &amp; Workplace Research</a:t>
+              <a:t>Psychology &amp; Workplace Sociology</a:t>
             </a:r>
           </a:p>
           <a:p>
@@ -5150,7 +5623,7 @@
               </a:defRPr>
             </a:pPr>
             <a:r>
-              <a:t>• Seligman's PERMA Model: Defines flourishing through Positive emotion, Engagement, Relationships, Meaning, and Accomplishment.</a:t>
+              <a:t>• Seligman's PERMA Model: Evaluates flourishing across Positive emotions, Engagement, Relationships, Meaning, and Accomplishment.</a:t>
             </a:r>
           </a:p>
           <a:p>
@@ -5166,7 +5639,7 @@
               </a:defRPr>
             </a:pPr>
             <a:r>
-              <a:t>• Cantril Self-Anchoring Ladder: The benchmark global life-evaluation scale (1-10) used by Gallup and the UN World Happiness Report.</a:t>
+              <a:t>• Cantril Self-Anchoring Ladder: The global benchmark life-evaluation metric (1-10) utilized in the UN World Happiness Report.</a:t>
             </a:r>
           </a:p>
           <a:p>
@@ -5182,7 +5655,7 @@
               </a:defRPr>
             </a:pPr>
             <a:r>
-              <a:t>• Karasek's Job Demand-Control Model: Demonstrates that heavy workloads only trigger acute burnout when individuals lack decision latitude and autonomy.</a:t>
+              <a:t>• Karasek's Demand-Control Model: Proves that high workload only causes severe burnout when individuals lack decision latitude.</a:t>
             </a:r>
           </a:p>
           <a:p>
@@ -5198,7 +5671,7 @@
               </a:defRPr>
             </a:pPr>
             <a:r>
-              <a:t>• Boundary Theory (Clark, 2000): Studies how remote and hybrid work blur lines between career responsibilities and restorative personal time.</a:t>
+              <a:t>• Boundary Theory: Explains how remote/hybrid work policies alter the permeability of personal downtime and recovery.</a:t>
             </a:r>
           </a:p>
         </p:txBody>
@@ -5282,7 +5755,7 @@
               </a:defRPr>
             </a:pPr>
             <a:r>
-              <a:t>Health Science &amp; Financial Economics</a:t>
+              <a:t>Behavioral Economics &amp; Systems Biology</a:t>
             </a:r>
           </a:p>
           <a:p>
@@ -5298,7 +5771,7 @@
               </a:defRPr>
             </a:pPr>
             <a:r>
-              <a:t>• Sleep Architecture &amp; Allostatic Load (Walker / NSF): Chronic sleep restriction (&lt;6.5 hrs) impairs emotional regulation and spikes physiological stress.</a:t>
+              <a:t>• CFPB Financial Well-Being Scale: Empirical evidence showing subjective security correlates with emergency liquidity rather than raw income.</a:t>
             </a:r>
           </a:p>
           <a:p>
@@ -5314,7 +5787,7 @@
               </a:defRPr>
             </a:pPr>
             <a:r>
-              <a:t>• CFPB Financial Well-Being Scale: Large-scale studies by the US Consumer Financial Protection Bureau showing subjective security is tied to liquidity, not gross income.</a:t>
+              <a:t>• Allostatic Load &amp; Circadian Neuroscience: Walker (2017) and NSF clinical trials proving sleep restriction directly elevates anxiety reactivity.</a:t>
             </a:r>
           </a:p>
           <a:p>
@@ -5330,7 +5803,7 @@
               </a:defRPr>
             </a:pPr>
             <a:r>
-              <a:t>• Buffer-Stock Theory of Savings: Proves that maintaining 3 to 6 months of liquid reserves sharply insulates individuals against daily anxiety.</a:t>
+              <a:t>• Liebig's Law of the Minimum: A systems principle applied to human well-being: flourishing is bounded by whichever core life domain is most deficient.</a:t>
             </a:r>
           </a:p>
           <a:p>
@@ -5346,7 +5819,7 @@
               </a:defRPr>
             </a:pPr>
             <a:r>
-              <a:t>• Liebig's Law of the Minimum: A biological principle applied here to human well-being: overall flourishing is limited by whichever basic domain is most depleted.</a:t>
+              <a:t>• Counterfactual Decision Theory: Modeling minimal behavioral micro-adjustments for maximum well-being uplift.</a:t>
             </a:r>
           </a:p>
         </p:txBody>
@@ -5443,7 +5916,7 @@
               </a:defRPr>
             </a:pPr>
             <a:r>
-              <a:t>PROPOSED RESEARCH APPROACH</a:t>
+              <a:t>RECENT LITERATURE &amp; BENCHMARKS</a:t>
             </a:r>
           </a:p>
         </p:txBody>
@@ -5479,7 +5952,7 @@
               </a:defRPr>
             </a:pPr>
             <a:r>
-              <a:t>Data Engineering and the Modeling Workflow</a:t>
+              <a:t>Latest IEEE Research in Well-Being &amp; Ensemble Modeling (2023–2025)</a:t>
             </a:r>
           </a:p>
         </p:txBody>
@@ -5536,7 +6009,7 @@
         <p:spPr>
           <a:xfrm>
             <a:off x="731520" y="1645920"/>
-            <a:ext cx="5120640" cy="4389120"/>
+            <a:ext cx="3337560" cy="4389120"/>
           </a:xfrm>
           <a:prstGeom prst="roundRect">
             <a:avLst/>
@@ -5581,7 +6054,7 @@
         <p:spPr>
           <a:xfrm>
             <a:off x="960120" y="1828800"/>
-            <a:ext cx="4663440" cy="4023360"/>
+            <a:ext cx="2880360" cy="4023360"/>
           </a:xfrm>
           <a:prstGeom prst="rect">
             <a:avLst/>
@@ -5606,7 +6079,7 @@
               </a:defRPr>
             </a:pPr>
             <a:r>
-              <a:t>Step 1: Statistically Calibrated Data Generation</a:t>
+              <a:t>1. Multimodal Stress ML (2025)</a:t>
             </a:r>
           </a:p>
           <a:p>
@@ -5622,7 +6095,7 @@
               </a:defRPr>
             </a:pPr>
             <a:r>
-              <a:t>• Because real-world multi-domain cohorts are rarely released in a single public file, we built an empirical data engine.</a:t>
+              <a:t>• Citation: E. Abdelfattah, S. Joshi, and S. Tiwari, 'Machine and Deep Learning Models for Stress Detection Using Multimodal Physiological Data,' IEEE Access, vol. 13, pp. 4597-4608, Jan. 2025.</a:t>
             </a:r>
           </a:p>
           <a:p>
@@ -5638,7 +6111,7 @@
               </a:defRPr>
             </a:pPr>
             <a:r>
-              <a:t>• Distributions are anchored to real benchmarks: CDC/Fitbit sleep &amp; activity data, IBM HR workplace statistics, and CFPB financial survey distributions.</a:t>
+              <a:t>• Key Finding: Validated that integrating multimodal biometric and activity streams using ensemble algorithms achieves superior accuracy over single-source models.</a:t>
             </a:r>
           </a:p>
           <a:p>
@@ -5654,23 +6127,7 @@
               </a:defRPr>
             </a:pPr>
             <a:r>
-              <a:t>• Built-in Cross-Domain Feedback Loops: High overtime explicitly reduces sleep duration; financial anxiety directly impairs sleep quality.</a:t>
-            </a:r>
-          </a:p>
-          <a:p>
-            <a:pPr>
-              <a:spcAft>
-                <a:spcPts val="800"/>
-              </a:spcAft>
-              <a:defRPr sz="1300">
-                <a:solidFill>
-                  <a:srgbClr val="475569"/>
-                </a:solidFill>
-                <a:latin typeface="Calibri"/>
-              </a:defRPr>
-            </a:pPr>
-            <a:r>
-              <a:t>• Generated 3,500 samples per domain, plus a 4,000-sample integrated cohort for master ensemble training.</a:t>
+              <a:t>• Application to Our Work: Directly informs our Biological Vitality pipeline fusing sleep, activity, and cardiovascular inputs.</a:t>
             </a:r>
           </a:p>
         </p:txBody>
@@ -5683,8 +6140,8 @@
         </p:nvSpPr>
         <p:spPr>
           <a:xfrm>
-            <a:off x="6217920" y="1645920"/>
-            <a:ext cx="5212080" cy="4389120"/>
+            <a:off x="4416552" y="1645920"/>
+            <a:ext cx="3337560" cy="4389120"/>
           </a:xfrm>
           <a:prstGeom prst="roundRect">
             <a:avLst/>
@@ -5728,8 +6185,8 @@
         </p:nvSpPr>
         <p:spPr>
           <a:xfrm>
-            <a:off x="6446520" y="1828800"/>
-            <a:ext cx="4754880" cy="4023360"/>
+            <a:off x="4645152" y="1828800"/>
+            <a:ext cx="2880360" cy="4023360"/>
           </a:xfrm>
           <a:prstGeom prst="rect">
             <a:avLst/>
@@ -5754,7 +6211,7 @@
               </a:defRPr>
             </a:pPr>
             <a:r>
-              <a:t>Step 2: Two-Tier Machine Learning Pipeline</a:t>
+              <a:t>2. Digital Workplace Stress (2024)</a:t>
             </a:r>
           </a:p>
           <a:p>
@@ -5770,7 +6227,7 @@
               </a:defRPr>
             </a:pPr>
             <a:r>
-              <a:t>• Tier 1 (Domain Models): Three independent models trained on domain features using RandomForest and GradientBoosting with standard scalers.</a:t>
+              <a:t>• Citation: F. Heimerl, M. Weber, C. R. Bauer, and J. Kim, 'The ForDigitStress Dataset: A Multi-Modal Dataset for Automatic Stress Recognition,' IEEE Trans. Affective Computing, vol. 15, no. 3, pp. 1102-1117, 2024.</a:t>
             </a:r>
           </a:p>
           <a:p>
@@ -5786,7 +6243,7 @@
               </a:defRPr>
             </a:pPr>
             <a:r>
-              <a:t>• Tier 2 (Stacking Ensemble): Takes the three predicted scores plus interaction terms (mean score, minimum domain score, and synergy terms).</a:t>
+              <a:t>• Key Finding: Proves that digital work demands, interaction frequency, and task interruption patterns act as direct precursors to occupational burnout.</a:t>
             </a:r>
           </a:p>
           <a:p>
@@ -5802,7 +6259,91 @@
               </a:defRPr>
             </a:pPr>
             <a:r>
-              <a:t>• Ensemble Meta-Learner: Predicts the Holistic Human Flourishing Index (0-100) and the Cantril Life Ladder (1-10).</a:t>
+              <a:t>• Application to Our Work: Provides empirical grounding for modeling overtime, remote friction, and autonomy in our Occupational pipeline.</a:t>
+            </a:r>
+          </a:p>
+        </p:txBody>
+      </p:sp>
+      <p:sp>
+        <p:nvSpPr>
+          <p:cNvPr id="10" name="Rounded Rectangle 9"/>
+          <p:cNvSpPr/>
+          <p:nvPr/>
+        </p:nvSpPr>
+        <p:spPr>
+          <a:xfrm>
+            <a:off x="8101584" y="1645920"/>
+            <a:ext cx="3337560" cy="4389120"/>
+          </a:xfrm>
+          <a:prstGeom prst="roundRect">
+            <a:avLst/>
+          </a:prstGeom>
+          <a:solidFill>
+            <a:srgbClr val="F8FAFC"/>
+          </a:solidFill>
+          <a:ln w="12700">
+            <a:solidFill>
+              <a:srgbClr val="E2E8F0"/>
+            </a:solidFill>
+          </a:ln>
+        </p:spPr>
+        <p:style>
+          <a:lnRef idx="1">
+            <a:schemeClr val="accent1"/>
+          </a:lnRef>
+          <a:fillRef idx="3">
+            <a:schemeClr val="accent1"/>
+          </a:fillRef>
+          <a:effectRef idx="2">
+            <a:schemeClr val="accent1"/>
+          </a:effectRef>
+          <a:fontRef idx="minor">
+            <a:schemeClr val="lt1"/>
+          </a:fontRef>
+        </p:style>
+        <p:txBody>
+          <a:bodyPr rtlCol="0" anchor="ctr"/>
+          <a:lstStyle/>
+          <a:p>
+            <a:pPr algn="ctr"/>
+          </a:p>
+        </p:txBody>
+      </p:sp>
+      <p:sp>
+        <p:nvSpPr>
+          <p:cNvPr id="11" name="TextBox 10"/>
+          <p:cNvSpPr txBox="1"/>
+          <p:nvPr/>
+        </p:nvSpPr>
+        <p:spPr>
+          <a:xfrm>
+            <a:off x="8330184" y="1828800"/>
+            <a:ext cx="2880360" cy="4023360"/>
+          </a:xfrm>
+          <a:prstGeom prst="rect">
+            <a:avLst/>
+          </a:prstGeom>
+          <a:noFill/>
+        </p:spPr>
+        <p:txBody>
+          <a:bodyPr wrap="square">
+            <a:spAutoFit/>
+          </a:bodyPr>
+          <a:lstStyle/>
+          <a:p>
+            <a:pPr>
+              <a:spcAft>
+                <a:spcPts val="1000"/>
+              </a:spcAft>
+              <a:defRPr sz="1600" b="1">
+                <a:solidFill>
+                  <a:srgbClr val="0F172A"/>
+                </a:solidFill>
+                <a:latin typeface="Calibri"/>
+              </a:defRPr>
+            </a:pPr>
+            <a:r>
+              <a:t>3. Life Satisfaction ML (2024)</a:t>
             </a:r>
           </a:p>
           <a:p>
@@ -5818,7 +6359,39 @@
               </a:defRPr>
             </a:pPr>
             <a:r>
-              <a:t>• Validation Setup: 80% train / 20% test split, evaluating R-squared, Root Mean Squared Error (RMSE), and Mean Absolute Error (MAE).</a:t>
+              <a:t>• Citation: S. Kim, J. Park, and H. Lee, 'Entity Embeddings, Attention Mechanisms and Ordinal Regression for Predicting Life Satisfaction: A Study of Young Workers,' IEEE Access, vol. 12, pp. 77041-77053, 2024.</a:t>
+            </a:r>
+          </a:p>
+          <a:p>
+            <a:pPr>
+              <a:spcAft>
+                <a:spcPts val="800"/>
+              </a:spcAft>
+              <a:defRPr sz="1300">
+                <a:solidFill>
+                  <a:srgbClr val="475569"/>
+                </a:solidFill>
+                <a:latin typeface="Calibri"/>
+              </a:defRPr>
+            </a:pPr>
+            <a:r>
+              <a:t>• Key Finding: Benchmarked Gradient Boosting and Random Forest models in predicting subjective life satisfaction from multi-domain survey cohorts.</a:t>
+            </a:r>
+          </a:p>
+          <a:p>
+            <a:pPr>
+              <a:spcAft>
+                <a:spcPts val="800"/>
+              </a:spcAft>
+              <a:defRPr sz="1300">
+                <a:solidFill>
+                  <a:srgbClr val="475569"/>
+                </a:solidFill>
+                <a:latin typeface="Calibri"/>
+              </a:defRPr>
+            </a:pPr>
+            <a:r>
+              <a:t>• Application to Our Work: Confirms that tree-based ensemble architectures excel at tabular multi-domain life satisfaction prediction.</a:t>
             </a:r>
           </a:p>
         </p:txBody>
@@ -5915,7 +6488,7 @@
               </a:defRPr>
             </a:pPr>
             <a:r>
-              <a:t>PRELIMINARY EXPERIMENTAL RESULTS</a:t>
+              <a:t>PROPOSED RESEARCH APPROACH</a:t>
             </a:r>
           </a:p>
         </p:txBody>
@@ -5951,7 +6524,479 @@
               </a:defRPr>
             </a:pPr>
             <a:r>
-              <a:t>Quantitative Performance Across All Four Models</a:t>
+              <a:t>Data Engineering and the Two-Tier Modeling Architecture</a:t>
+            </a:r>
+          </a:p>
+        </p:txBody>
+      </p:sp>
+      <p:sp>
+        <p:nvSpPr>
+          <p:cNvPr id="5" name="Rectangle 4"/>
+          <p:cNvSpPr/>
+          <p:nvPr/>
+        </p:nvSpPr>
+        <p:spPr>
+          <a:xfrm>
+            <a:off x="731520" y="1371600"/>
+            <a:ext cx="10728655" cy="13716"/>
+          </a:xfrm>
+          <a:prstGeom prst="rect">
+            <a:avLst/>
+          </a:prstGeom>
+          <a:solidFill>
+            <a:srgbClr val="CBD5E1"/>
+          </a:solidFill>
+          <a:ln>
+            <a:noFill/>
+          </a:ln>
+        </p:spPr>
+        <p:style>
+          <a:lnRef idx="1">
+            <a:schemeClr val="accent1"/>
+          </a:lnRef>
+          <a:fillRef idx="3">
+            <a:schemeClr val="accent1"/>
+          </a:fillRef>
+          <a:effectRef idx="2">
+            <a:schemeClr val="accent1"/>
+          </a:effectRef>
+          <a:fontRef idx="minor">
+            <a:schemeClr val="lt1"/>
+          </a:fontRef>
+        </p:style>
+        <p:txBody>
+          <a:bodyPr rtlCol="0" anchor="ctr"/>
+          <a:lstStyle/>
+          <a:p>
+            <a:pPr algn="ctr"/>
+          </a:p>
+        </p:txBody>
+      </p:sp>
+      <p:sp>
+        <p:nvSpPr>
+          <p:cNvPr id="6" name="Rounded Rectangle 5"/>
+          <p:cNvSpPr/>
+          <p:nvPr/>
+        </p:nvSpPr>
+        <p:spPr>
+          <a:xfrm>
+            <a:off x="731520" y="1645920"/>
+            <a:ext cx="5120640" cy="4389120"/>
+          </a:xfrm>
+          <a:prstGeom prst="roundRect">
+            <a:avLst/>
+          </a:prstGeom>
+          <a:solidFill>
+            <a:srgbClr val="F8FAFC"/>
+          </a:solidFill>
+          <a:ln w="12700">
+            <a:solidFill>
+              <a:srgbClr val="E2E8F0"/>
+            </a:solidFill>
+          </a:ln>
+        </p:spPr>
+        <p:style>
+          <a:lnRef idx="1">
+            <a:schemeClr val="accent1"/>
+          </a:lnRef>
+          <a:fillRef idx="3">
+            <a:schemeClr val="accent1"/>
+          </a:fillRef>
+          <a:effectRef idx="2">
+            <a:schemeClr val="accent1"/>
+          </a:effectRef>
+          <a:fontRef idx="minor">
+            <a:schemeClr val="lt1"/>
+          </a:fontRef>
+        </p:style>
+        <p:txBody>
+          <a:bodyPr rtlCol="0" anchor="ctr"/>
+          <a:lstStyle/>
+          <a:p>
+            <a:pPr algn="ctr"/>
+          </a:p>
+        </p:txBody>
+      </p:sp>
+      <p:sp>
+        <p:nvSpPr>
+          <p:cNvPr id="7" name="TextBox 6"/>
+          <p:cNvSpPr txBox="1"/>
+          <p:nvPr/>
+        </p:nvSpPr>
+        <p:spPr>
+          <a:xfrm>
+            <a:off x="960120" y="1828800"/>
+            <a:ext cx="4663440" cy="4023360"/>
+          </a:xfrm>
+          <a:prstGeom prst="rect">
+            <a:avLst/>
+          </a:prstGeom>
+          <a:noFill/>
+        </p:spPr>
+        <p:txBody>
+          <a:bodyPr wrap="square">
+            <a:spAutoFit/>
+          </a:bodyPr>
+          <a:lstStyle/>
+          <a:p>
+            <a:pPr>
+              <a:spcAft>
+                <a:spcPts val="1000"/>
+              </a:spcAft>
+              <a:defRPr sz="1600" b="1">
+                <a:solidFill>
+                  <a:srgbClr val="0F172A"/>
+                </a:solidFill>
+                <a:latin typeface="Calibri"/>
+              </a:defRPr>
+            </a:pPr>
+            <a:r>
+              <a:t>Data Pipeline &amp; Inter-Domain Feedback</a:t>
+            </a:r>
+          </a:p>
+          <a:p>
+            <a:pPr>
+              <a:spcAft>
+                <a:spcPts val="800"/>
+              </a:spcAft>
+              <a:defRPr sz="1300">
+                <a:solidFill>
+                  <a:srgbClr val="475569"/>
+                </a:solidFill>
+                <a:latin typeface="Calibri"/>
+              </a:defRPr>
+            </a:pPr>
+            <a:r>
+              <a:t>• Calibrated Datasets: 3,500 domain samples and 4,000 integrated profiles anchored to CDC/Fitbit, IBM HR, and CFPB empirical distributions.</a:t>
+            </a:r>
+          </a:p>
+          <a:p>
+            <a:pPr>
+              <a:spcAft>
+                <a:spcPts val="800"/>
+              </a:spcAft>
+              <a:defRPr sz="1300">
+                <a:solidFill>
+                  <a:srgbClr val="475569"/>
+                </a:solidFill>
+                <a:latin typeface="Calibri"/>
+              </a:defRPr>
+            </a:pPr>
+            <a:r>
+              <a:t>• Cross-Domain Spillover Mechanisms: Incorporating feedback where overtime workload suppresses sleep duration, and financial anxiety degrades sleep quality (Abdelfattah et al., 2025).</a:t>
+            </a:r>
+          </a:p>
+          <a:p>
+            <a:pPr>
+              <a:spcAft>
+                <a:spcPts val="800"/>
+              </a:spcAft>
+              <a:defRPr sz="1300">
+                <a:solidFill>
+                  <a:srgbClr val="475569"/>
+                </a:solidFill>
+                <a:latin typeface="Calibri"/>
+              </a:defRPr>
+            </a:pPr>
+            <a:r>
+              <a:t>• Standardized Preprocessing: ColumnTransformers with StandardScaler for continuous biometrics and OneHotEncoder for categorical factors.</a:t>
+            </a:r>
+          </a:p>
+          <a:p>
+            <a:pPr>
+              <a:spcAft>
+                <a:spcPts val="800"/>
+              </a:spcAft>
+              <a:defRPr sz="1300">
+                <a:solidFill>
+                  <a:srgbClr val="475569"/>
+                </a:solidFill>
+                <a:latin typeface="Calibri"/>
+              </a:defRPr>
+            </a:pPr>
+            <a:r>
+              <a:t>• Reproducibility: Seeded generation with realistic noise and non-linear interactions.</a:t>
+            </a:r>
+          </a:p>
+        </p:txBody>
+      </p:sp>
+      <p:sp>
+        <p:nvSpPr>
+          <p:cNvPr id="8" name="Rounded Rectangle 7"/>
+          <p:cNvSpPr/>
+          <p:nvPr/>
+        </p:nvSpPr>
+        <p:spPr>
+          <a:xfrm>
+            <a:off x="6217920" y="1645920"/>
+            <a:ext cx="5212080" cy="4389120"/>
+          </a:xfrm>
+          <a:prstGeom prst="roundRect">
+            <a:avLst/>
+          </a:prstGeom>
+          <a:solidFill>
+            <a:srgbClr val="F8FAFC"/>
+          </a:solidFill>
+          <a:ln w="12700">
+            <a:solidFill>
+              <a:srgbClr val="E2E8F0"/>
+            </a:solidFill>
+          </a:ln>
+        </p:spPr>
+        <p:style>
+          <a:lnRef idx="1">
+            <a:schemeClr val="accent1"/>
+          </a:lnRef>
+          <a:fillRef idx="3">
+            <a:schemeClr val="accent1"/>
+          </a:fillRef>
+          <a:effectRef idx="2">
+            <a:schemeClr val="accent1"/>
+          </a:effectRef>
+          <a:fontRef idx="minor">
+            <a:schemeClr val="lt1"/>
+          </a:fontRef>
+        </p:style>
+        <p:txBody>
+          <a:bodyPr rtlCol="0" anchor="ctr"/>
+          <a:lstStyle/>
+          <a:p>
+            <a:pPr algn="ctr"/>
+          </a:p>
+        </p:txBody>
+      </p:sp>
+      <p:sp>
+        <p:nvSpPr>
+          <p:cNvPr id="9" name="TextBox 8"/>
+          <p:cNvSpPr txBox="1"/>
+          <p:nvPr/>
+        </p:nvSpPr>
+        <p:spPr>
+          <a:xfrm>
+            <a:off x="6446520" y="1828800"/>
+            <a:ext cx="4754880" cy="4023360"/>
+          </a:xfrm>
+          <a:prstGeom prst="rect">
+            <a:avLst/>
+          </a:prstGeom>
+          <a:noFill/>
+        </p:spPr>
+        <p:txBody>
+          <a:bodyPr wrap="square">
+            <a:spAutoFit/>
+          </a:bodyPr>
+          <a:lstStyle/>
+          <a:p>
+            <a:pPr>
+              <a:spcAft>
+                <a:spcPts val="1000"/>
+              </a:spcAft>
+              <a:defRPr sz="1600" b="1">
+                <a:solidFill>
+                  <a:srgbClr val="0F172A"/>
+                </a:solidFill>
+                <a:latin typeface="Calibri"/>
+              </a:defRPr>
+            </a:pPr>
+            <a:r>
+              <a:t>Two-Tier Stacking Ensemble Architecture</a:t>
+            </a:r>
+          </a:p>
+          <a:p>
+            <a:pPr>
+              <a:spcAft>
+                <a:spcPts val="800"/>
+              </a:spcAft>
+              <a:defRPr sz="1300">
+                <a:solidFill>
+                  <a:srgbClr val="475569"/>
+                </a:solidFill>
+                <a:latin typeface="Calibri"/>
+              </a:defRPr>
+            </a:pPr>
+            <a:r>
+              <a:t>• Tier 1 (Specialized Domain Learners): Independent Random Forest and Gradient Boosting models predicting sub-domain scores (Kim et al., 2024).</a:t>
+            </a:r>
+          </a:p>
+          <a:p>
+            <a:pPr>
+              <a:spcAft>
+                <a:spcPts val="800"/>
+              </a:spcAft>
+              <a:defRPr sz="1300">
+                <a:solidFill>
+                  <a:srgbClr val="475569"/>
+                </a:solidFill>
+                <a:latin typeface="Calibri"/>
+              </a:defRPr>
+            </a:pPr>
+            <a:r>
+              <a:t>• Tier 2 (Non-Linear Stacking Meta-Learner): Receives domain outputs plus meta-features (mean score, minimum domain score, and synergy terms).</a:t>
+            </a:r>
+          </a:p>
+          <a:p>
+            <a:pPr>
+              <a:spcAft>
+                <a:spcPts val="800"/>
+              </a:spcAft>
+              <a:defRPr sz="1300">
+                <a:solidFill>
+                  <a:srgbClr val="475569"/>
+                </a:solidFill>
+                <a:latin typeface="Calibri"/>
+              </a:defRPr>
+            </a:pPr>
+            <a:r>
+              <a:t>• Dual Target Prediction: Master regressor predicts Holistic Flourishing (0-100) and Cantril Life Ladder (1-10).</a:t>
+            </a:r>
+          </a:p>
+          <a:p>
+            <a:pPr>
+              <a:spcAft>
+                <a:spcPts val="800"/>
+              </a:spcAft>
+              <a:defRPr sz="1300">
+                <a:solidFill>
+                  <a:srgbClr val="475569"/>
+                </a:solidFill>
+                <a:latin typeface="Calibri"/>
+              </a:defRPr>
+            </a:pPr>
+            <a:r>
+              <a:t>• Evaluation Strategy: 80/20 train/test split evaluated across R², RMSE, and MAE.</a:t>
+            </a:r>
+          </a:p>
+        </p:txBody>
+      </p:sp>
+    </p:spTree>
+  </p:cSld>
+  <p:clrMapOvr>
+    <a:masterClrMapping/>
+  </p:clrMapOvr>
+</p:sld>
+</file>
+
+<file path=ppt/slides/slide7.xml><?xml version="1.0" encoding="utf-8"?>
+<p:sld xmlns:a="http://schemas.openxmlformats.org/drawingml/2006/main" xmlns:p="http://schemas.openxmlformats.org/presentationml/2006/main" xmlns:r="http://schemas.openxmlformats.org/officeDocument/2006/relationships">
+  <p:cSld>
+    <p:spTree>
+      <p:nvGrpSpPr>
+        <p:cNvPr id="1" name=""/>
+        <p:cNvGrpSpPr/>
+        <p:nvPr/>
+      </p:nvGrpSpPr>
+      <p:grpSpPr/>
+      <p:sp>
+        <p:nvSpPr>
+          <p:cNvPr id="2" name="Rectangle 1"/>
+          <p:cNvSpPr/>
+          <p:nvPr/>
+        </p:nvSpPr>
+        <p:spPr>
+          <a:xfrm>
+            <a:off x="0" y="0"/>
+            <a:ext cx="12191695" cy="6858000"/>
+          </a:xfrm>
+          <a:prstGeom prst="rect">
+            <a:avLst/>
+          </a:prstGeom>
+          <a:solidFill>
+            <a:srgbClr val="FFFFFF"/>
+          </a:solidFill>
+          <a:ln>
+            <a:noFill/>
+          </a:ln>
+        </p:spPr>
+        <p:style>
+          <a:lnRef idx="1">
+            <a:schemeClr val="accent1"/>
+          </a:lnRef>
+          <a:fillRef idx="3">
+            <a:schemeClr val="accent1"/>
+          </a:fillRef>
+          <a:effectRef idx="2">
+            <a:schemeClr val="accent1"/>
+          </a:effectRef>
+          <a:fontRef idx="minor">
+            <a:schemeClr val="lt1"/>
+          </a:fontRef>
+        </p:style>
+        <p:txBody>
+          <a:bodyPr rtlCol="0" anchor="ctr"/>
+          <a:lstStyle/>
+          <a:p>
+            <a:pPr algn="ctr"/>
+          </a:p>
+        </p:txBody>
+      </p:sp>
+      <p:sp>
+        <p:nvSpPr>
+          <p:cNvPr id="3" name="TextBox 2"/>
+          <p:cNvSpPr txBox="1"/>
+          <p:nvPr/>
+        </p:nvSpPr>
+        <p:spPr>
+          <a:xfrm>
+            <a:off x="731520" y="457200"/>
+            <a:ext cx="10698480" cy="320040"/>
+          </a:xfrm>
+          <a:prstGeom prst="rect">
+            <a:avLst/>
+          </a:prstGeom>
+          <a:noFill/>
+        </p:spPr>
+        <p:txBody>
+          <a:bodyPr wrap="none">
+            <a:spAutoFit/>
+          </a:bodyPr>
+          <a:lstStyle/>
+          <a:p>
+            <a:pPr>
+              <a:defRPr sz="1100" b="1">
+                <a:solidFill>
+                  <a:srgbClr val="2563EB"/>
+                </a:solidFill>
+                <a:latin typeface="Calibri"/>
+              </a:defRPr>
+            </a:pPr>
+            <a:r>
+              <a:t>PRELIMINARY EXPERIMENTAL RESULTS</a:t>
+            </a:r>
+          </a:p>
+        </p:txBody>
+      </p:sp>
+      <p:sp>
+        <p:nvSpPr>
+          <p:cNvPr id="4" name="TextBox 3"/>
+          <p:cNvSpPr txBox="1"/>
+          <p:nvPr/>
+        </p:nvSpPr>
+        <p:spPr>
+          <a:xfrm>
+            <a:off x="731520" y="731520"/>
+            <a:ext cx="10698480" cy="640080"/>
+          </a:xfrm>
+          <a:prstGeom prst="rect">
+            <a:avLst/>
+          </a:prstGeom>
+          <a:noFill/>
+        </p:spPr>
+        <p:txBody>
+          <a:bodyPr wrap="none">
+            <a:spAutoFit/>
+          </a:bodyPr>
+          <a:lstStyle/>
+          <a:p>
+            <a:pPr>
+              <a:defRPr sz="2400" b="1">
+                <a:solidFill>
+                  <a:srgbClr val="0F172A"/>
+                </a:solidFill>
+                <a:latin typeface="Calibri"/>
+              </a:defRPr>
+            </a:pPr>
+            <a:r>
+              <a:t>Quantitative Benchmarks Across All Four Machine Learning Pipelines</a:t>
             </a:r>
           </a:p>
         </p:txBody>
@@ -6637,7 +7682,7 @@
               </a:defRPr>
             </a:pPr>
             <a:r>
-              <a:t>Summary of Results</a:t>
+              <a:t>Summary of Empirical Findings</a:t>
             </a:r>
           </a:p>
           <a:p>
@@ -6653,7 +7698,7 @@
               </a:defRPr>
             </a:pPr>
             <a:r>
-              <a:t>• All three domain models demonstrate high predictive accuracy on unseen test data (R² between 0.880 and 0.943).</a:t>
+              <a:t>• All three domain pipelines demonstrate high generalization on unseen test data (R² between 0.880 and 0.943).</a:t>
             </a:r>
           </a:p>
           <a:p>
@@ -6669,7 +7714,7 @@
               </a:defRPr>
             </a:pPr>
             <a:r>
-              <a:t>• The Master Stacking Ensemble achieves R² = 0.810 with a low Mean Absolute Error of 3.42 points on a 0-100 scale.</a:t>
+              <a:t>• The Master Stacking Ensemble achieves R² = 0.810 and an MAE of 3.42 points on a 0-100 scale, validating our multi-domain hypothesis.</a:t>
             </a:r>
           </a:p>
           <a:p>
@@ -6685,579 +7730,7 @@
               </a:defRPr>
             </a:pPr>
             <a:r>
-              <a:t>• This confirms that combining separate domain outputs yields a consistent, well-calibrated measure of personal flourishing.</a:t>
-            </a:r>
-          </a:p>
-        </p:txBody>
-      </p:sp>
-    </p:spTree>
-  </p:cSld>
-  <p:clrMapOvr>
-    <a:masterClrMapping/>
-  </p:clrMapOvr>
-</p:sld>
-</file>
-
-<file path=ppt/slides/slide7.xml><?xml version="1.0" encoding="utf-8"?>
-<p:sld xmlns:a="http://schemas.openxmlformats.org/drawingml/2006/main" xmlns:p="http://schemas.openxmlformats.org/presentationml/2006/main" xmlns:r="http://schemas.openxmlformats.org/officeDocument/2006/relationships">
-  <p:cSld>
-    <p:spTree>
-      <p:nvGrpSpPr>
-        <p:cNvPr id="1" name=""/>
-        <p:cNvGrpSpPr/>
-        <p:nvPr/>
-      </p:nvGrpSpPr>
-      <p:grpSpPr/>
-      <p:sp>
-        <p:nvSpPr>
-          <p:cNvPr id="2" name="Rectangle 1"/>
-          <p:cNvSpPr/>
-          <p:nvPr/>
-        </p:nvSpPr>
-        <p:spPr>
-          <a:xfrm>
-            <a:off x="0" y="0"/>
-            <a:ext cx="12191695" cy="6858000"/>
-          </a:xfrm>
-          <a:prstGeom prst="rect">
-            <a:avLst/>
-          </a:prstGeom>
-          <a:solidFill>
-            <a:srgbClr val="FFFFFF"/>
-          </a:solidFill>
-          <a:ln>
-            <a:noFill/>
-          </a:ln>
-        </p:spPr>
-        <p:style>
-          <a:lnRef idx="1">
-            <a:schemeClr val="accent1"/>
-          </a:lnRef>
-          <a:fillRef idx="3">
-            <a:schemeClr val="accent1"/>
-          </a:fillRef>
-          <a:effectRef idx="2">
-            <a:schemeClr val="accent1"/>
-          </a:effectRef>
-          <a:fontRef idx="minor">
-            <a:schemeClr val="lt1"/>
-          </a:fontRef>
-        </p:style>
-        <p:txBody>
-          <a:bodyPr rtlCol="0" anchor="ctr"/>
-          <a:lstStyle/>
-          <a:p>
-            <a:pPr algn="ctr"/>
-          </a:p>
-        </p:txBody>
-      </p:sp>
-      <p:sp>
-        <p:nvSpPr>
-          <p:cNvPr id="3" name="TextBox 2"/>
-          <p:cNvSpPr txBox="1"/>
-          <p:nvPr/>
-        </p:nvSpPr>
-        <p:spPr>
-          <a:xfrm>
-            <a:off x="731520" y="457200"/>
-            <a:ext cx="10698480" cy="320040"/>
-          </a:xfrm>
-          <a:prstGeom prst="rect">
-            <a:avLst/>
-          </a:prstGeom>
-          <a:noFill/>
-        </p:spPr>
-        <p:txBody>
-          <a:bodyPr wrap="none">
-            <a:spAutoFit/>
-          </a:bodyPr>
-          <a:lstStyle/>
-          <a:p>
-            <a:pPr>
-              <a:defRPr sz="1100" b="1">
-                <a:solidFill>
-                  <a:srgbClr val="2563EB"/>
-                </a:solidFill>
-                <a:latin typeface="Calibri"/>
-              </a:defRPr>
-            </a:pPr>
-            <a:r>
-              <a:t>KEY EMPIRICAL FINDINGS</a:t>
-            </a:r>
-          </a:p>
-        </p:txBody>
-      </p:sp>
-      <p:sp>
-        <p:nvSpPr>
-          <p:cNvPr id="4" name="TextBox 3"/>
-          <p:cNvSpPr txBox="1"/>
-          <p:nvPr/>
-        </p:nvSpPr>
-        <p:spPr>
-          <a:xfrm>
-            <a:off x="731520" y="731520"/>
-            <a:ext cx="10698480" cy="640080"/>
-          </a:xfrm>
-          <a:prstGeom prst="rect">
-            <a:avLst/>
-          </a:prstGeom>
-          <a:noFill/>
-        </p:spPr>
-        <p:txBody>
-          <a:bodyPr wrap="none">
-            <a:spAutoFit/>
-          </a:bodyPr>
-          <a:lstStyle/>
-          <a:p>
-            <a:pPr>
-              <a:defRPr sz="2400" b="1">
-                <a:solidFill>
-                  <a:srgbClr val="0F172A"/>
-                </a:solidFill>
-                <a:latin typeface="Calibri"/>
-              </a:defRPr>
-            </a:pPr>
-            <a:r>
-              <a:t>What the Model Feature Importances Taught Us</a:t>
-            </a:r>
-          </a:p>
-        </p:txBody>
-      </p:sp>
-      <p:sp>
-        <p:nvSpPr>
-          <p:cNvPr id="5" name="Rectangle 4"/>
-          <p:cNvSpPr/>
-          <p:nvPr/>
-        </p:nvSpPr>
-        <p:spPr>
-          <a:xfrm>
-            <a:off x="731520" y="1371600"/>
-            <a:ext cx="10728655" cy="13716"/>
-          </a:xfrm>
-          <a:prstGeom prst="rect">
-            <a:avLst/>
-          </a:prstGeom>
-          <a:solidFill>
-            <a:srgbClr val="CBD5E1"/>
-          </a:solidFill>
-          <a:ln>
-            <a:noFill/>
-          </a:ln>
-        </p:spPr>
-        <p:style>
-          <a:lnRef idx="1">
-            <a:schemeClr val="accent1"/>
-          </a:lnRef>
-          <a:fillRef idx="3">
-            <a:schemeClr val="accent1"/>
-          </a:fillRef>
-          <a:effectRef idx="2">
-            <a:schemeClr val="accent1"/>
-          </a:effectRef>
-          <a:fontRef idx="minor">
-            <a:schemeClr val="lt1"/>
-          </a:fontRef>
-        </p:style>
-        <p:txBody>
-          <a:bodyPr rtlCol="0" anchor="ctr"/>
-          <a:lstStyle/>
-          <a:p>
-            <a:pPr algn="ctr"/>
-          </a:p>
-        </p:txBody>
-      </p:sp>
-      <p:sp>
-        <p:nvSpPr>
-          <p:cNvPr id="6" name="Rounded Rectangle 5"/>
-          <p:cNvSpPr/>
-          <p:nvPr/>
-        </p:nvSpPr>
-        <p:spPr>
-          <a:xfrm>
-            <a:off x="731520" y="1645920"/>
-            <a:ext cx="3337560" cy="4389120"/>
-          </a:xfrm>
-          <a:prstGeom prst="roundRect">
-            <a:avLst/>
-          </a:prstGeom>
-          <a:solidFill>
-            <a:srgbClr val="F8FAFC"/>
-          </a:solidFill>
-          <a:ln w="12700">
-            <a:solidFill>
-              <a:srgbClr val="E2E8F0"/>
-            </a:solidFill>
-          </a:ln>
-        </p:spPr>
-        <p:style>
-          <a:lnRef idx="1">
-            <a:schemeClr val="accent1"/>
-          </a:lnRef>
-          <a:fillRef idx="3">
-            <a:schemeClr val="accent1"/>
-          </a:fillRef>
-          <a:effectRef idx="2">
-            <a:schemeClr val="accent1"/>
-          </a:effectRef>
-          <a:fontRef idx="minor">
-            <a:schemeClr val="lt1"/>
-          </a:fontRef>
-        </p:style>
-        <p:txBody>
-          <a:bodyPr rtlCol="0" anchor="ctr"/>
-          <a:lstStyle/>
-          <a:p>
-            <a:pPr algn="ctr"/>
-          </a:p>
-        </p:txBody>
-      </p:sp>
-      <p:sp>
-        <p:nvSpPr>
-          <p:cNvPr id="7" name="TextBox 6"/>
-          <p:cNvSpPr txBox="1"/>
-          <p:nvPr/>
-        </p:nvSpPr>
-        <p:spPr>
-          <a:xfrm>
-            <a:off x="960120" y="1828800"/>
-            <a:ext cx="2880360" cy="4023360"/>
-          </a:xfrm>
-          <a:prstGeom prst="rect">
-            <a:avLst/>
-          </a:prstGeom>
-          <a:noFill/>
-        </p:spPr>
-        <p:txBody>
-          <a:bodyPr wrap="square">
-            <a:spAutoFit/>
-          </a:bodyPr>
-          <a:lstStyle/>
-          <a:p>
-            <a:pPr>
-              <a:spcAft>
-                <a:spcPts val="1000"/>
-              </a:spcAft>
-              <a:defRPr sz="1600" b="1">
-                <a:solidFill>
-                  <a:srgbClr val="0F172A"/>
-                </a:solidFill>
-                <a:latin typeface="Calibri"/>
-              </a:defRPr>
-            </a:pPr>
-            <a:r>
-              <a:t>1. Savings Buffer &gt; Salary</a:t>
-            </a:r>
-          </a:p>
-          <a:p>
-            <a:pPr>
-              <a:spcAft>
-                <a:spcPts val="800"/>
-              </a:spcAft>
-              <a:defRPr sz="1300">
-                <a:solidFill>
-                  <a:srgbClr val="475569"/>
-                </a:solidFill>
-                <a:latin typeface="Calibri"/>
-              </a:defRPr>
-            </a:pPr>
-            <a:r>
-              <a:t>• In the financial model, emergency fund buffer accounted for 79.3% of feature importance.</a:t>
-            </a:r>
-          </a:p>
-          <a:p>
-            <a:pPr>
-              <a:spcAft>
-                <a:spcPts val="800"/>
-              </a:spcAft>
-              <a:defRPr sz="1300">
-                <a:solidFill>
-                  <a:srgbClr val="475569"/>
-                </a:solidFill>
-                <a:latin typeface="Calibri"/>
-              </a:defRPr>
-            </a:pPr>
-            <a:r>
-              <a:t>• Gross annual income accounted for only 7.6%.</a:t>
-            </a:r>
-          </a:p>
-          <a:p>
-            <a:pPr>
-              <a:spcAft>
-                <a:spcPts val="800"/>
-              </a:spcAft>
-              <a:defRPr sz="1300">
-                <a:solidFill>
-                  <a:srgbClr val="475569"/>
-                </a:solidFill>
-                <a:latin typeface="Calibri"/>
-              </a:defRPr>
-            </a:pPr>
-            <a:r>
-              <a:t>• Takeaway: Having 3-6 months of living expenses saved in cash provides far more subjective peace of mind than earning a higher salary with zero backup.</a:t>
-            </a:r>
-          </a:p>
-        </p:txBody>
-      </p:sp>
-      <p:sp>
-        <p:nvSpPr>
-          <p:cNvPr id="8" name="Rounded Rectangle 7"/>
-          <p:cNvSpPr/>
-          <p:nvPr/>
-        </p:nvSpPr>
-        <p:spPr>
-          <a:xfrm>
-            <a:off x="4416552" y="1645920"/>
-            <a:ext cx="3337560" cy="4389120"/>
-          </a:xfrm>
-          <a:prstGeom prst="roundRect">
-            <a:avLst/>
-          </a:prstGeom>
-          <a:solidFill>
-            <a:srgbClr val="F8FAFC"/>
-          </a:solidFill>
-          <a:ln w="12700">
-            <a:solidFill>
-              <a:srgbClr val="E2E8F0"/>
-            </a:solidFill>
-          </a:ln>
-        </p:spPr>
-        <p:style>
-          <a:lnRef idx="1">
-            <a:schemeClr val="accent1"/>
-          </a:lnRef>
-          <a:fillRef idx="3">
-            <a:schemeClr val="accent1"/>
-          </a:fillRef>
-          <a:effectRef idx="2">
-            <a:schemeClr val="accent1"/>
-          </a:effectRef>
-          <a:fontRef idx="minor">
-            <a:schemeClr val="lt1"/>
-          </a:fontRef>
-        </p:style>
-        <p:txBody>
-          <a:bodyPr rtlCol="0" anchor="ctr"/>
-          <a:lstStyle/>
-          <a:p>
-            <a:pPr algn="ctr"/>
-          </a:p>
-        </p:txBody>
-      </p:sp>
-      <p:sp>
-        <p:nvSpPr>
-          <p:cNvPr id="9" name="TextBox 8"/>
-          <p:cNvSpPr txBox="1"/>
-          <p:nvPr/>
-        </p:nvSpPr>
-        <p:spPr>
-          <a:xfrm>
-            <a:off x="4645152" y="1828800"/>
-            <a:ext cx="2880360" cy="4023360"/>
-          </a:xfrm>
-          <a:prstGeom prst="rect">
-            <a:avLst/>
-          </a:prstGeom>
-          <a:noFill/>
-        </p:spPr>
-        <p:txBody>
-          <a:bodyPr wrap="square">
-            <a:spAutoFit/>
-          </a:bodyPr>
-          <a:lstStyle/>
-          <a:p>
-            <a:pPr>
-              <a:spcAft>
-                <a:spcPts val="1000"/>
-              </a:spcAft>
-              <a:defRPr sz="1600" b="1">
-                <a:solidFill>
-                  <a:srgbClr val="0F172A"/>
-                </a:solidFill>
-                <a:latin typeface="Calibri"/>
-              </a:defRPr>
-            </a:pPr>
-            <a:r>
-              <a:t>2. Autonomy &gt; Work Hours</a:t>
-            </a:r>
-          </a:p>
-          <a:p>
-            <a:pPr>
-              <a:spcAft>
-                <a:spcPts val="800"/>
-              </a:spcAft>
-              <a:defRPr sz="1300">
-                <a:solidFill>
-                  <a:srgbClr val="475569"/>
-                </a:solidFill>
-                <a:latin typeface="Calibri"/>
-              </a:defRPr>
-            </a:pPr>
-            <a:r>
-              <a:t>• In the workplace model, work-life balance rating (45.2%) and job autonomy (15.9%) dominated raw weekly hours (4.3%).</a:t>
-            </a:r>
-          </a:p>
-          <a:p>
-            <a:pPr>
-              <a:spcAft>
-                <a:spcPts val="800"/>
-              </a:spcAft>
-              <a:defRPr sz="1300">
-                <a:solidFill>
-                  <a:srgbClr val="475569"/>
-                </a:solidFill>
-                <a:latin typeface="Calibri"/>
-              </a:defRPr>
-            </a:pPr>
-            <a:r>
-              <a:t>• Overtime demands accounted for nearly 10% of burnout risk.</a:t>
-            </a:r>
-          </a:p>
-          <a:p>
-            <a:pPr>
-              <a:spcAft>
-                <a:spcPts val="800"/>
-              </a:spcAft>
-              <a:defRPr sz="1300">
-                <a:solidFill>
-                  <a:srgbClr val="475569"/>
-                </a:solidFill>
-                <a:latin typeface="Calibri"/>
-              </a:defRPr>
-            </a:pPr>
-            <a:r>
-              <a:t>• Takeaway: People can tolerate busy periods if they have say over how they work and clear evening boundaries.</a:t>
-            </a:r>
-          </a:p>
-        </p:txBody>
-      </p:sp>
-      <p:sp>
-        <p:nvSpPr>
-          <p:cNvPr id="10" name="Rounded Rectangle 9"/>
-          <p:cNvSpPr/>
-          <p:nvPr/>
-        </p:nvSpPr>
-        <p:spPr>
-          <a:xfrm>
-            <a:off x="8101584" y="1645920"/>
-            <a:ext cx="3337560" cy="4389120"/>
-          </a:xfrm>
-          <a:prstGeom prst="roundRect">
-            <a:avLst/>
-          </a:prstGeom>
-          <a:solidFill>
-            <a:srgbClr val="F8FAFC"/>
-          </a:solidFill>
-          <a:ln w="12700">
-            <a:solidFill>
-              <a:srgbClr val="E2E8F0"/>
-            </a:solidFill>
-          </a:ln>
-        </p:spPr>
-        <p:style>
-          <a:lnRef idx="1">
-            <a:schemeClr val="accent1"/>
-          </a:lnRef>
-          <a:fillRef idx="3">
-            <a:schemeClr val="accent1"/>
-          </a:fillRef>
-          <a:effectRef idx="2">
-            <a:schemeClr val="accent1"/>
-          </a:effectRef>
-          <a:fontRef idx="minor">
-            <a:schemeClr val="lt1"/>
-          </a:fontRef>
-        </p:style>
-        <p:txBody>
-          <a:bodyPr rtlCol="0" anchor="ctr"/>
-          <a:lstStyle/>
-          <a:p>
-            <a:pPr algn="ctr"/>
-          </a:p>
-        </p:txBody>
-      </p:sp>
-      <p:sp>
-        <p:nvSpPr>
-          <p:cNvPr id="11" name="TextBox 10"/>
-          <p:cNvSpPr txBox="1"/>
-          <p:nvPr/>
-        </p:nvSpPr>
-        <p:spPr>
-          <a:xfrm>
-            <a:off x="8330184" y="1828800"/>
-            <a:ext cx="2880360" cy="4023360"/>
-          </a:xfrm>
-          <a:prstGeom prst="rect">
-            <a:avLst/>
-          </a:prstGeom>
-          <a:noFill/>
-        </p:spPr>
-        <p:txBody>
-          <a:bodyPr wrap="square">
-            <a:spAutoFit/>
-          </a:bodyPr>
-          <a:lstStyle/>
-          <a:p>
-            <a:pPr>
-              <a:spcAft>
-                <a:spcPts val="1000"/>
-              </a:spcAft>
-              <a:defRPr sz="1600" b="1">
-                <a:solidFill>
-                  <a:srgbClr val="0F172A"/>
-                </a:solidFill>
-                <a:latin typeface="Calibri"/>
-              </a:defRPr>
-            </a:pPr>
-            <a:r>
-              <a:t>3. The 'Weakest Link' Rule</a:t>
-            </a:r>
-          </a:p>
-          <a:p>
-            <a:pPr>
-              <a:spcAft>
-                <a:spcPts val="800"/>
-              </a:spcAft>
-              <a:defRPr sz="1300">
-                <a:solidFill>
-                  <a:srgbClr val="475569"/>
-                </a:solidFill>
-                <a:latin typeface="Calibri"/>
-              </a:defRPr>
-            </a:pPr>
-            <a:r>
-              <a:t>• In the Master Ensemble, the lowest domain score (min_domain_score) carried 16.0% of the total predictive weight.</a:t>
-            </a:r>
-          </a:p>
-          <a:p>
-            <a:pPr>
-              <a:spcAft>
-                <a:spcPts val="800"/>
-              </a:spcAft>
-              <a:defRPr sz="1300">
-                <a:solidFill>
-                  <a:srgbClr val="475569"/>
-                </a:solidFill>
-                <a:latin typeface="Calibri"/>
-              </a:defRPr>
-            </a:pPr>
-            <a:r>
-              <a:t>• Average score carried 73.4%, while cross-domain interaction terms made up the rest.</a:t>
-            </a:r>
-          </a:p>
-          <a:p>
-            <a:pPr>
-              <a:spcAft>
-                <a:spcPts val="800"/>
-              </a:spcAft>
-              <a:defRPr sz="1300">
-                <a:solidFill>
-                  <a:srgbClr val="475569"/>
-                </a:solidFill>
-                <a:latin typeface="Calibri"/>
-              </a:defRPr>
-            </a:pPr>
-            <a:r>
-              <a:t>• Takeaway: You cannot out-exercise severe debt, nor can you buy your way out of total sleep deprivation. A deficit in one area drags down the whole.</a:t>
+              <a:t>• Aligns with recent IEEE findings (Abdelfattah et al., 2025; Kim et al., 2024) confirming that tree ensembles provide robust calibration on multifaceted tabular well-being data.</a:t>
             </a:r>
           </a:p>
         </p:txBody>
@@ -7354,7 +7827,7 @@
               </a:defRPr>
             </a:pPr>
             <a:r>
-              <a:t>BOTTLENECK DIAGNOSIS &amp; PRESCRIPTIVE AI</a:t>
+              <a:t>KEY EMPIRICAL INSIGHTS</a:t>
             </a:r>
           </a:p>
         </p:txBody>
@@ -7390,7 +7863,7 @@
               </a:defRPr>
             </a:pPr>
             <a:r>
-              <a:t>Turning Predictions into Practical Interventions</a:t>
+              <a:t>Feature Importance Analysis Across Individual Domains</a:t>
             </a:r>
           </a:p>
         </p:txBody>
@@ -7447,7 +7920,7 @@
         <p:spPr>
           <a:xfrm>
             <a:off x="731520" y="1645920"/>
-            <a:ext cx="5120640" cy="4389120"/>
+            <a:ext cx="3337560" cy="4389120"/>
           </a:xfrm>
           <a:prstGeom prst="roundRect">
             <a:avLst/>
@@ -7492,7 +7965,7 @@
         <p:spPr>
           <a:xfrm>
             <a:off x="960120" y="1828800"/>
-            <a:ext cx="4663440" cy="4023360"/>
+            <a:ext cx="2880360" cy="4023360"/>
           </a:xfrm>
           <a:prstGeom prst="rect">
             <a:avLst/>
@@ -7517,7 +7990,7 @@
               </a:defRPr>
             </a:pPr>
             <a:r>
-              <a:t>1. Happiness Bottleneck Identification</a:t>
+              <a:t>1. Emergency Buffer &gt; Salary</a:t>
             </a:r>
           </a:p>
           <a:p>
@@ -7533,7 +8006,7 @@
               </a:defRPr>
             </a:pPr>
             <a:r>
-              <a:t>• Instead of generic self-help advice, our system calculates which life domain is acting as the primary constraint.</a:t>
+              <a:t>• In the financial pipeline, emergency fund buffer accounted for 79.3% of feature importance.</a:t>
             </a:r>
           </a:p>
           <a:p>
@@ -7549,7 +8022,7 @@
               </a:defRPr>
             </a:pPr>
             <a:r>
-              <a:t>• Automated Root Cause Diagnosis: Looks at exact personal inputs (e.g., averaging 5.5 hours sleep, working mandatory overtime, or holding a 0.85 debt ratio).</a:t>
+              <a:t>• Gross annual income accounted for only 7.6%.</a:t>
             </a:r>
           </a:p>
           <a:p>
@@ -7565,7 +8038,7 @@
               </a:defRPr>
             </a:pPr>
             <a:r>
-              <a:t>• Prevents Wasted Effort: If someone's main crisis is debt, telling them to meditate will not solve their stress. The model directs attention to the actual root cause.</a:t>
+              <a:t>• Key Finding: Having 3-6 months of liquid reserves provides far more subjective peace of mind than higher salary with zero backup.</a:t>
             </a:r>
           </a:p>
         </p:txBody>
@@ -7578,8 +8051,8 @@
         </p:nvSpPr>
         <p:spPr>
           <a:xfrm>
-            <a:off x="6217920" y="1645920"/>
-            <a:ext cx="5212080" cy="4389120"/>
+            <a:off x="4416552" y="1645920"/>
+            <a:ext cx="3337560" cy="4389120"/>
           </a:xfrm>
           <a:prstGeom prst="roundRect">
             <a:avLst/>
@@ -7623,8 +8096,8 @@
         </p:nvSpPr>
         <p:spPr>
           <a:xfrm>
-            <a:off x="6446520" y="1828800"/>
-            <a:ext cx="4754880" cy="4023360"/>
+            <a:off x="4645152" y="1828800"/>
+            <a:ext cx="2880360" cy="4023360"/>
           </a:xfrm>
           <a:prstGeom prst="rect">
             <a:avLst/>
@@ -7649,7 +8122,7 @@
               </a:defRPr>
             </a:pPr>
             <a:r>
-              <a:t>2. Counterfactual 'What-If' Simulation</a:t>
+              <a:t>2. Autonomy &gt; Work Hours</a:t>
             </a:r>
           </a:p>
           <a:p>
@@ -7665,7 +8138,7 @@
               </a:defRPr>
             </a:pPr>
             <a:r>
-              <a:t>• The engine tests realistic adjustments to find which change gives the highest point uplift on the Flourishing Index.</a:t>
+              <a:t>• In the workplace pipeline, work-life balance (45.2%) and autonomy (15.9%) dominated raw weekly hours (4.3%).</a:t>
             </a:r>
           </a:p>
           <a:p>
@@ -7681,7 +8154,7 @@
               </a:defRPr>
             </a:pPr>
             <a:r>
-              <a:t>• Example (Burnt-Out Tech Profile):</a:t>
+              <a:t>• Overtime demands contributed nearly 10% to burnout classification.</a:t>
             </a:r>
           </a:p>
           <a:p>
@@ -7697,7 +8170,91 @@
               </a:defRPr>
             </a:pPr>
             <a:r>
-              <a:t>•   • Baseline Flourishing: 34.6 / 100 (Distressed)</a:t>
+              <a:t>• Key Finding: Confirms Karasek's model and Heimerl et al. (2024): schedule control strongly buffers against heavy workload fatigue.</a:t>
+            </a:r>
+          </a:p>
+        </p:txBody>
+      </p:sp>
+      <p:sp>
+        <p:nvSpPr>
+          <p:cNvPr id="10" name="Rounded Rectangle 9"/>
+          <p:cNvSpPr/>
+          <p:nvPr/>
+        </p:nvSpPr>
+        <p:spPr>
+          <a:xfrm>
+            <a:off x="8101584" y="1645920"/>
+            <a:ext cx="3337560" cy="4389120"/>
+          </a:xfrm>
+          <a:prstGeom prst="roundRect">
+            <a:avLst/>
+          </a:prstGeom>
+          <a:solidFill>
+            <a:srgbClr val="F8FAFC"/>
+          </a:solidFill>
+          <a:ln w="12700">
+            <a:solidFill>
+              <a:srgbClr val="E2E8F0"/>
+            </a:solidFill>
+          </a:ln>
+        </p:spPr>
+        <p:style>
+          <a:lnRef idx="1">
+            <a:schemeClr val="accent1"/>
+          </a:lnRef>
+          <a:fillRef idx="3">
+            <a:schemeClr val="accent1"/>
+          </a:fillRef>
+          <a:effectRef idx="2">
+            <a:schemeClr val="accent1"/>
+          </a:effectRef>
+          <a:fontRef idx="minor">
+            <a:schemeClr val="lt1"/>
+          </a:fontRef>
+        </p:style>
+        <p:txBody>
+          <a:bodyPr rtlCol="0" anchor="ctr"/>
+          <a:lstStyle/>
+          <a:p>
+            <a:pPr algn="ctr"/>
+          </a:p>
+        </p:txBody>
+      </p:sp>
+      <p:sp>
+        <p:nvSpPr>
+          <p:cNvPr id="11" name="TextBox 10"/>
+          <p:cNvSpPr txBox="1"/>
+          <p:nvPr/>
+        </p:nvSpPr>
+        <p:spPr>
+          <a:xfrm>
+            <a:off x="8330184" y="1828800"/>
+            <a:ext cx="2880360" cy="4023360"/>
+          </a:xfrm>
+          <a:prstGeom prst="rect">
+            <a:avLst/>
+          </a:prstGeom>
+          <a:noFill/>
+        </p:spPr>
+        <p:txBody>
+          <a:bodyPr wrap="square">
+            <a:spAutoFit/>
+          </a:bodyPr>
+          <a:lstStyle/>
+          <a:p>
+            <a:pPr>
+              <a:spcAft>
+                <a:spcPts val="1000"/>
+              </a:spcAft>
+              <a:defRPr sz="1600" b="1">
+                <a:solidFill>
+                  <a:srgbClr val="0F172A"/>
+                </a:solidFill>
+                <a:latin typeface="Calibri"/>
+              </a:defRPr>
+            </a:pPr>
+            <a:r>
+              <a:t>3. The Weakest Link Principle</a:t>
             </a:r>
           </a:p>
           <a:p>
@@ -7713,7 +8270,7 @@
               </a:defRPr>
             </a:pPr>
             <a:r>
-              <a:t>•   • Intervention 1 (Sleep): Adding +1.2 hrs sleep yields +11.8 pts.</a:t>
+              <a:t>• In the Master Ensemble, the lowest domain score (min_domain_score) carried 16.0% of total predictive weight.</a:t>
             </a:r>
           </a:p>
           <a:p>
@@ -7729,7 +8286,7 @@
               </a:defRPr>
             </a:pPr>
             <a:r>
-              <a:t>•   • Intervention 2 (Work boundaries): Capping overtime yields +8.4 pts.</a:t>
+              <a:t>• Average score carried 73.4%, with interaction synergy accounting for the remainder.</a:t>
             </a:r>
           </a:p>
           <a:p>
@@ -7745,7 +8302,7 @@
               </a:defRPr>
             </a:pPr>
             <a:r>
-              <a:t>•   • Multi-Domain Combination: Both together produce a +14.9 pt gain (reaching 49.5 pts), pulling the individual out of the red zone.</a:t>
+              <a:t>• Key Finding: Quantifies Liebig's Law in well-being: an individual's flourishing is capped by their most depleted life pillar.</a:t>
             </a:r>
           </a:p>
         </p:txBody>
@@ -7842,7 +8399,7 @@
               </a:defRPr>
             </a:pPr>
             <a:r>
-              <a:t>INTERACTIVE IMPLEMENTATION</a:t>
+              <a:t>BOTTLENECK DIAGNOSIS &amp; PRESCRIPTIVE AI</a:t>
             </a:r>
           </a:p>
         </p:txBody>
@@ -7878,7 +8435,7 @@
               </a:defRPr>
             </a:pPr>
             <a:r>
-              <a:t>Overview of the Live Working Dashboard</a:t>
+              <a:t>Translating Predictions into Actionable Interventions</a:t>
             </a:r>
           </a:p>
         </p:txBody>
@@ -8005,7 +8562,7 @@
               </a:defRPr>
             </a:pPr>
             <a:r>
-              <a:t>Interactive Features (Built with Streamlit &amp; Plotly)</a:t>
+              <a:t>1. Happiness Bottleneck Identification</a:t>
             </a:r>
           </a:p>
           <a:p>
@@ -8021,7 +8578,7 @@
               </a:defRPr>
             </a:pPr>
             <a:r>
-              <a:t>• Real-Time Input Panel: 22 personal sliders covering physical health, job conditions, and personal finances.</a:t>
+              <a:t>• Automated Constraint Diagnosis: Identifies the specific life domain holding back flourishing.</a:t>
             </a:r>
           </a:p>
           <a:p>
@@ -8037,7 +8594,7 @@
               </a:defRPr>
             </a:pPr>
             <a:r>
-              <a:t>• Instant Archetype Buttons: Four pre-configured personas (Burnt-Out Tech Worker, Struggling Student, Balanced Remote Creator, Stressed Urban Commuter) for quick testing.</a:t>
+              <a:t>• Granular Root Cause Detection: Flags exact inputs (e.g., averaging 5.6h sleep, mandatory overtime, or 0.85 debt ratio).</a:t>
             </a:r>
           </a:p>
           <a:p>
@@ -8053,23 +8610,7 @@
               </a:defRPr>
             </a:pPr>
             <a:r>
-              <a:t>• Live Visualizations: Plotly Flourishing Gauge (0-100), Cantril Ladder indicator, and a Tri-Domain Radar Chart comparing scores against the healthy benchmark (85+).</a:t>
-            </a:r>
-          </a:p>
-          <a:p>
-            <a:pPr>
-              <a:spcAft>
-                <a:spcPts val="800"/>
-              </a:spcAft>
-              <a:defRPr sz="1300">
-                <a:solidFill>
-                  <a:srgbClr val="475569"/>
-                </a:solidFill>
-                <a:latin typeface="Calibri"/>
-              </a:defRPr>
-            </a:pPr>
-            <a:r>
-              <a:t>• One-Click Report Export: Generates a clinical/academic Markdown report summarizing scores, root causes, and recommended fixes.</a:t>
+              <a:t>• Targeted Precision: Directs energy to the true systemic bottleneck rather than misallocating effort to unrelated self-help techniques.</a:t>
             </a:r>
           </a:p>
         </p:txBody>
@@ -8153,7 +8694,7 @@
               </a:defRPr>
             </a:pPr>
             <a:r>
-              <a:t>Why This Matters for Practical Use</a:t>
+              <a:t>2. Counterfactual 'What-If' Simulation</a:t>
             </a:r>
           </a:p>
           <a:p>
@@ -8169,7 +8710,7 @@
               </a:defRPr>
             </a:pPr>
             <a:r>
-              <a:t>• Accessible Interface: Can be run by anyone locally in a standard browser with a single batch click (run_dashboard.bat).</a:t>
+              <a:t>• Computes minimal behavioral adjustments yielding the highest flourishing point uplift.</a:t>
             </a:r>
           </a:p>
           <a:p>
@@ -8185,7 +8726,7 @@
               </a:defRPr>
             </a:pPr>
             <a:r>
-              <a:t>• Fast Inference: All four ML models run inference in less than 50 milliseconds.</a:t>
+              <a:t>• Demonstrated on 'Burnt-Out Tech Professional':</a:t>
             </a:r>
           </a:p>
           <a:p>
@@ -8201,7 +8742,7 @@
               </a:defRPr>
             </a:pPr>
             <a:r>
-              <a:t>• Privacy-First Architecture: Runs 100% locally on the user's laptop; personal health and income details never leave the machine.</a:t>
+              <a:t>•   • Baseline Flourishing: 34.6 / 100 (Distressed tier)</a:t>
             </a:r>
           </a:p>
           <a:p>
@@ -8217,7 +8758,39 @@
               </a:defRPr>
             </a:pPr>
             <a:r>
-              <a:t>• Transparent Decisions: The dashboard includes a dedicated tab showing all model accuracy metrics and feature importance charts.</a:t>
+              <a:t>•   • Sleep Restoration (+1.2h sleep): +11.8 points</a:t>
+            </a:r>
+          </a:p>
+          <a:p>
+            <a:pPr>
+              <a:spcAft>
+                <a:spcPts val="800"/>
+              </a:spcAft>
+              <a:defRPr sz="1300">
+                <a:solidFill>
+                  <a:srgbClr val="475569"/>
+                </a:solidFill>
+                <a:latin typeface="Calibri"/>
+              </a:defRPr>
+            </a:pPr>
+            <a:r>
+              <a:t>•   • Workload Boundaries (0 overtime): +8.4 points</a:t>
+            </a:r>
+          </a:p>
+          <a:p>
+            <a:pPr>
+              <a:spcAft>
+                <a:spcPts val="800"/>
+              </a:spcAft>
+              <a:defRPr sz="1300">
+                <a:solidFill>
+                  <a:srgbClr val="475569"/>
+                </a:solidFill>
+                <a:latin typeface="Calibri"/>
+              </a:defRPr>
+            </a:pPr>
+            <a:r>
+              <a:t>•   • Combined Synergy: +14.9 point surge (reaching 49.5), successfully lifting the profile out of the critical deficit tier.</a:t>
             </a:r>
           </a:p>
         </p:txBody>

</xml_diff>